<commit_message>
Add milestone illustrations to editable self-intro slide
Embed circular icon images for Xi'an, Japan arrival, lab research,
and Yokogawa career while keeping text boxes and shapes editable.

Co-authored-by: zhexingwang <zhexingwang@users.noreply.github.com>
</commit_message>
<xml_diff>
--- a/output/self_intro.pptx
+++ b/output/self_intro.pptx
@@ -3148,7 +3148,7 @@
         <p:spPr>
           <a:xfrm>
             <a:off x="0" y="0"/>
-            <a:ext cx="12191695" cy="566928"/>
+            <a:ext cx="12191695" cy="530352"/>
           </a:xfrm>
           <a:prstGeom prst="rect">
             <a:avLst/>
@@ -3190,8 +3190,8 @@
         </p:nvSpPr>
         <p:spPr>
           <a:xfrm>
-            <a:off x="411480" y="73152"/>
-            <a:ext cx="3657600" cy="438912"/>
+            <a:off x="411480" y="54864"/>
+            <a:ext cx="3657600" cy="411480"/>
           </a:xfrm>
           <a:prstGeom prst="rect">
             <a:avLst/>
@@ -3225,8 +3225,8 @@
         </p:nvSpPr>
         <p:spPr>
           <a:xfrm>
-            <a:off x="411480" y="777240"/>
-            <a:ext cx="4937760" cy="960120"/>
+            <a:off x="411480" y="685800"/>
+            <a:ext cx="4937760" cy="868680"/>
           </a:xfrm>
           <a:prstGeom prst="roundRect">
             <a:avLst>
@@ -3270,8 +3270,8 @@
         </p:nvSpPr>
         <p:spPr>
           <a:xfrm>
-            <a:off x="411480" y="777240"/>
-            <a:ext cx="4937760" cy="960120"/>
+            <a:off x="411480" y="685800"/>
+            <a:ext cx="4937760" cy="868680"/>
           </a:xfrm>
           <a:prstGeom prst="roundRect">
             <a:avLst>
@@ -3315,8 +3315,8 @@
         </p:nvSpPr>
         <p:spPr>
           <a:xfrm>
-            <a:off x="640080" y="868680"/>
-            <a:ext cx="4572000" cy="411480"/>
+            <a:off x="640080" y="749808"/>
+            <a:ext cx="4572000" cy="384048"/>
           </a:xfrm>
           <a:prstGeom prst="rect">
             <a:avLst/>
@@ -3331,7 +3331,7 @@
           <a:p>
             <a:pPr algn="l"/>
             <a:r>
-              <a:rPr sz="2800" b="1">
+              <a:rPr sz="2600" b="1">
                 <a:solidFill>
                   <a:srgbClr val="1F4E79"/>
                 </a:solidFill>
@@ -3350,8 +3350,8 @@
         </p:nvSpPr>
         <p:spPr>
           <a:xfrm>
-            <a:off x="640080" y="1280160"/>
-            <a:ext cx="4572000" cy="320040"/>
+            <a:off x="640080" y="1143000"/>
+            <a:ext cx="4572000" cy="292608"/>
           </a:xfrm>
           <a:prstGeom prst="rect">
             <a:avLst/>
@@ -3385,8 +3385,8 @@
         </p:nvSpPr>
         <p:spPr>
           <a:xfrm>
-            <a:off x="5669280" y="914400"/>
-            <a:ext cx="6035040" cy="640080"/>
+            <a:off x="5669280" y="822960"/>
+            <a:ext cx="6035040" cy="548640"/>
           </a:xfrm>
           <a:prstGeom prst="rect">
             <a:avLst/>
@@ -3420,13 +3420,13 @@
         </p:nvCxnSpPr>
         <p:spPr>
           <a:xfrm>
-            <a:off x="1802739.5" y="2560320.0"/>
+            <a:off x="1802739.5" y="2400300.0"/>
             <a:ext cx="8586216.0" cy="0.0"/>
           </a:xfrm>
           <a:prstGeom prst="line">
             <a:avLst/>
           </a:prstGeom>
-          <a:ln w="28575">
+          <a:ln w="31750">
             <a:solidFill>
               <a:srgbClr val="F2C94C"/>
             </a:solidFill>
@@ -3449,20 +3449,20 @@
       </p:cxnSp>
       <p:sp>
         <p:nvSpPr>
-          <p:cNvPr id="10" name="Oval 9"/>
+          <p:cNvPr id="10" name="Right Arrow 9"/>
           <p:cNvSpPr/>
           <p:nvPr/>
         </p:nvSpPr>
         <p:spPr>
           <a:xfrm>
-            <a:off x="1391259" y="2148840"/>
-            <a:ext cx="822960" cy="822960"/>
-          </a:xfrm>
-          <a:prstGeom prst="ellipse">
+            <a:off x="3124047" y="2308860"/>
+            <a:ext cx="219456" cy="182880"/>
+          </a:xfrm>
+          <a:prstGeom prst="rightArrow">
             <a:avLst/>
           </a:prstGeom>
           <a:solidFill>
-            <a:srgbClr val="1F4E79"/>
+            <a:srgbClr val="F2C94C"/>
           </a:solidFill>
           <a:ln>
             <a:noFill/>
@@ -3492,14 +3492,210 @@
       </p:sp>
       <p:sp>
         <p:nvSpPr>
-          <p:cNvPr id="11" name="TextBox 10"/>
+          <p:cNvPr id="11" name="Right Arrow 10"/>
+          <p:cNvSpPr/>
+          <p:nvPr/>
+        </p:nvSpPr>
+        <p:spPr>
+          <a:xfrm>
+            <a:off x="5986119" y="2308860"/>
+            <a:ext cx="219456" cy="182880"/>
+          </a:xfrm>
+          <a:prstGeom prst="rightArrow">
+            <a:avLst/>
+          </a:prstGeom>
+          <a:solidFill>
+            <a:srgbClr val="F2C94C"/>
+          </a:solidFill>
+          <a:ln>
+            <a:noFill/>
+          </a:ln>
+        </p:spPr>
+        <p:style>
+          <a:lnRef idx="1">
+            <a:schemeClr val="accent1"/>
+          </a:lnRef>
+          <a:fillRef idx="3">
+            <a:schemeClr val="accent1"/>
+          </a:fillRef>
+          <a:effectRef idx="2">
+            <a:schemeClr val="accent1"/>
+          </a:effectRef>
+          <a:fontRef idx="minor">
+            <a:schemeClr val="lt1"/>
+          </a:fontRef>
+        </p:style>
+        <p:txBody>
+          <a:bodyPr rtlCol="0" anchor="ctr"/>
+          <a:lstStyle/>
+          <a:p>
+            <a:pPr algn="ctr"/>
+          </a:p>
+        </p:txBody>
+      </p:sp>
+      <p:sp>
+        <p:nvSpPr>
+          <p:cNvPr id="12" name="Right Arrow 11"/>
+          <p:cNvSpPr/>
+          <p:nvPr/>
+        </p:nvSpPr>
+        <p:spPr>
+          <a:xfrm>
+            <a:off x="8848191" y="2308860"/>
+            <a:ext cx="219456" cy="182880"/>
+          </a:xfrm>
+          <a:prstGeom prst="rightArrow">
+            <a:avLst/>
+          </a:prstGeom>
+          <a:solidFill>
+            <a:srgbClr val="F2C94C"/>
+          </a:solidFill>
+          <a:ln>
+            <a:noFill/>
+          </a:ln>
+        </p:spPr>
+        <p:style>
+          <a:lnRef idx="1">
+            <a:schemeClr val="accent1"/>
+          </a:lnRef>
+          <a:fillRef idx="3">
+            <a:schemeClr val="accent1"/>
+          </a:fillRef>
+          <a:effectRef idx="2">
+            <a:schemeClr val="accent1"/>
+          </a:effectRef>
+          <a:fontRef idx="minor">
+            <a:schemeClr val="lt1"/>
+          </a:fontRef>
+        </p:style>
+        <p:txBody>
+          <a:bodyPr rtlCol="0" anchor="ctr"/>
+          <a:lstStyle/>
+          <a:p>
+            <a:pPr algn="ctr"/>
+          </a:p>
+        </p:txBody>
+      </p:sp>
+      <p:sp>
+        <p:nvSpPr>
+          <p:cNvPr id="13" name="Oval 12"/>
+          <p:cNvSpPr/>
+          <p:nvPr/>
+        </p:nvSpPr>
+        <p:spPr>
+          <a:xfrm>
+            <a:off x="1222095" y="1819656"/>
+            <a:ext cx="1234440" cy="1234440"/>
+          </a:xfrm>
+          <a:prstGeom prst="ellipse">
+            <a:avLst/>
+          </a:prstGeom>
+          <a:solidFill>
+            <a:srgbClr val="D0D8E0"/>
+          </a:solidFill>
+          <a:ln>
+            <a:noFill/>
+          </a:ln>
+        </p:spPr>
+        <p:style>
+          <a:lnRef idx="1">
+            <a:schemeClr val="accent1"/>
+          </a:lnRef>
+          <a:fillRef idx="3">
+            <a:schemeClr val="accent1"/>
+          </a:fillRef>
+          <a:effectRef idx="2">
+            <a:schemeClr val="accent1"/>
+          </a:effectRef>
+          <a:fontRef idx="minor">
+            <a:schemeClr val="lt1"/>
+          </a:fontRef>
+        </p:style>
+        <p:txBody>
+          <a:bodyPr rtlCol="0" anchor="ctr"/>
+          <a:lstStyle/>
+          <a:p>
+            <a:pPr algn="ctr"/>
+          </a:p>
+        </p:txBody>
+      </p:sp>
+      <p:pic>
+        <p:nvPicPr>
+          <p:cNvPr id="14" name="Picture 13" descr="icon_xian_circle.png"/>
+          <p:cNvPicPr>
+            <a:picLocks noChangeAspect="1"/>
+          </p:cNvPicPr>
+          <p:nvPr/>
+        </p:nvPicPr>
+        <p:blipFill>
+          <a:blip r:embed="rId2"/>
+          <a:stretch>
+            <a:fillRect/>
+          </a:stretch>
+        </p:blipFill>
+        <p:spPr>
+          <a:xfrm>
+            <a:off x="1185519" y="1783080"/>
+            <a:ext cx="1234440" cy="1234440"/>
+          </a:xfrm>
+          <a:prstGeom prst="rect">
+            <a:avLst/>
+          </a:prstGeom>
+        </p:spPr>
+      </p:pic>
+      <p:sp>
+        <p:nvSpPr>
+          <p:cNvPr id="15" name="Oval 14"/>
+          <p:cNvSpPr/>
+          <p:nvPr/>
+        </p:nvSpPr>
+        <p:spPr>
+          <a:xfrm>
+            <a:off x="1167231" y="1764792"/>
+            <a:ext cx="292608" cy="292608"/>
+          </a:xfrm>
+          <a:prstGeom prst="ellipse">
+            <a:avLst/>
+          </a:prstGeom>
+          <a:solidFill>
+            <a:srgbClr val="F2C94C"/>
+          </a:solidFill>
+          <a:ln>
+            <a:noFill/>
+          </a:ln>
+        </p:spPr>
+        <p:style>
+          <a:lnRef idx="1">
+            <a:schemeClr val="accent1"/>
+          </a:lnRef>
+          <a:fillRef idx="3">
+            <a:schemeClr val="accent1"/>
+          </a:fillRef>
+          <a:effectRef idx="2">
+            <a:schemeClr val="accent1"/>
+          </a:effectRef>
+          <a:fontRef idx="minor">
+            <a:schemeClr val="lt1"/>
+          </a:fontRef>
+        </p:style>
+        <p:txBody>
+          <a:bodyPr rtlCol="0" anchor="ctr"/>
+          <a:lstStyle/>
+          <a:p>
+            <a:pPr algn="ctr"/>
+          </a:p>
+        </p:txBody>
+      </p:sp>
+      <p:sp>
+        <p:nvSpPr>
+          <p:cNvPr id="16" name="TextBox 15"/>
           <p:cNvSpPr txBox="1"/>
           <p:nvPr/>
         </p:nvSpPr>
         <p:spPr>
           <a:xfrm>
-            <a:off x="1391259" y="2331720"/>
-            <a:ext cx="822960" cy="457200"/>
+            <a:off x="1167231" y="1764792"/>
+            <a:ext cx="292608" cy="292608"/>
           </a:xfrm>
           <a:prstGeom prst="rect">
             <a:avLst/>
@@ -3514,9 +3710,9 @@
           <a:p>
             <a:pPr algn="ctr"/>
             <a:r>
-              <a:rPr sz="1800" b="1">
+              <a:rPr sz="1000" b="1">
                 <a:solidFill>
-                  <a:srgbClr val="FFFFFF"/>
+                  <a:srgbClr val="1F4E79"/>
                 </a:solidFill>
                 <a:latin typeface="Noto Sans CJK JP"/>
               </a:rPr>
@@ -3527,14 +3723,14 @@
       </p:sp>
       <p:sp>
         <p:nvSpPr>
-          <p:cNvPr id="12" name="Rounded Rectangle 11"/>
+          <p:cNvPr id="17" name="Rounded Rectangle 16"/>
           <p:cNvSpPr/>
           <p:nvPr/>
         </p:nvSpPr>
         <p:spPr>
           <a:xfrm>
-            <a:off x="453999" y="3200400"/>
-            <a:ext cx="2697480" cy="1188720"/>
+            <a:off x="453999" y="3246120"/>
+            <a:ext cx="2697480" cy="1097280"/>
           </a:xfrm>
           <a:prstGeom prst="roundRect">
             <a:avLst>
@@ -3572,14 +3768,14 @@
       </p:sp>
       <p:sp>
         <p:nvSpPr>
-          <p:cNvPr id="13" name="Rectangle 12"/>
+          <p:cNvPr id="18" name="Rectangle 17"/>
           <p:cNvSpPr/>
           <p:nvPr/>
         </p:nvSpPr>
         <p:spPr>
           <a:xfrm>
-            <a:off x="453999" y="3200400"/>
-            <a:ext cx="109728" cy="1188720"/>
+            <a:off x="453999" y="3246120"/>
+            <a:ext cx="109728" cy="1097280"/>
           </a:xfrm>
           <a:prstGeom prst="rect">
             <a:avLst/>
@@ -3615,13 +3811,13 @@
       </p:sp>
       <p:sp>
         <p:nvSpPr>
-          <p:cNvPr id="14" name="TextBox 13"/>
+          <p:cNvPr id="19" name="TextBox 18"/>
           <p:cNvSpPr txBox="1"/>
           <p:nvPr/>
         </p:nvSpPr>
         <p:spPr>
           <a:xfrm>
-            <a:off x="655167" y="3310128"/>
+            <a:off x="655167" y="3355848"/>
             <a:ext cx="2377440" cy="320040"/>
           </a:xfrm>
           <a:prstGeom prst="rect">
@@ -3650,13 +3846,13 @@
       </p:sp>
       <p:sp>
         <p:nvSpPr>
-          <p:cNvPr id="15" name="TextBox 14"/>
+          <p:cNvPr id="20" name="TextBox 19"/>
           <p:cNvSpPr txBox="1"/>
           <p:nvPr/>
         </p:nvSpPr>
         <p:spPr>
           <a:xfrm>
-            <a:off x="655167" y="3611880"/>
+            <a:off x="655167" y="3657600"/>
             <a:ext cx="2377440" cy="502920"/>
           </a:xfrm>
           <a:prstGeom prst="rect">
@@ -3685,20 +3881,20 @@
       </p:sp>
       <p:sp>
         <p:nvSpPr>
-          <p:cNvPr id="16" name="Oval 15"/>
+          <p:cNvPr id="21" name="Oval 20"/>
           <p:cNvSpPr/>
           <p:nvPr/>
         </p:nvSpPr>
         <p:spPr>
           <a:xfrm>
-            <a:off x="4253331" y="2148840"/>
-            <a:ext cx="822960" cy="822960"/>
+            <a:off x="4084167" y="1819656"/>
+            <a:ext cx="1234440" cy="1234440"/>
           </a:xfrm>
           <a:prstGeom prst="ellipse">
             <a:avLst/>
           </a:prstGeom>
           <a:solidFill>
-            <a:srgbClr val="1F4E79"/>
+            <a:srgbClr val="D0D8E0"/>
           </a:solidFill>
           <a:ln>
             <a:noFill/>
@@ -3726,16 +3922,83 @@
           </a:p>
         </p:txBody>
       </p:sp>
-      <p:sp>
-        <p:nvSpPr>
-          <p:cNvPr id="17" name="TextBox 16"/>
+      <p:pic>
+        <p:nvPicPr>
+          <p:cNvPr id="22" name="Picture 21" descr="icon_japan_circle.png"/>
+          <p:cNvPicPr>
+            <a:picLocks noChangeAspect="1"/>
+          </p:cNvPicPr>
+          <p:nvPr/>
+        </p:nvPicPr>
+        <p:blipFill>
+          <a:blip r:embed="rId3"/>
+          <a:stretch>
+            <a:fillRect/>
+          </a:stretch>
+        </p:blipFill>
+        <p:spPr>
+          <a:xfrm>
+            <a:off x="4047591" y="1783080"/>
+            <a:ext cx="1234440" cy="1234440"/>
+          </a:xfrm>
+          <a:prstGeom prst="rect">
+            <a:avLst/>
+          </a:prstGeom>
+        </p:spPr>
+      </p:pic>
+      <p:sp>
+        <p:nvSpPr>
+          <p:cNvPr id="23" name="Oval 22"/>
+          <p:cNvSpPr/>
+          <p:nvPr/>
+        </p:nvSpPr>
+        <p:spPr>
+          <a:xfrm>
+            <a:off x="4029303" y="1764792"/>
+            <a:ext cx="292608" cy="292608"/>
+          </a:xfrm>
+          <a:prstGeom prst="ellipse">
+            <a:avLst/>
+          </a:prstGeom>
+          <a:solidFill>
+            <a:srgbClr val="F2C94C"/>
+          </a:solidFill>
+          <a:ln>
+            <a:noFill/>
+          </a:ln>
+        </p:spPr>
+        <p:style>
+          <a:lnRef idx="1">
+            <a:schemeClr val="accent1"/>
+          </a:lnRef>
+          <a:fillRef idx="3">
+            <a:schemeClr val="accent1"/>
+          </a:fillRef>
+          <a:effectRef idx="2">
+            <a:schemeClr val="accent1"/>
+          </a:effectRef>
+          <a:fontRef idx="minor">
+            <a:schemeClr val="lt1"/>
+          </a:fontRef>
+        </p:style>
+        <p:txBody>
+          <a:bodyPr rtlCol="0" anchor="ctr"/>
+          <a:lstStyle/>
+          <a:p>
+            <a:pPr algn="ctr"/>
+          </a:p>
+        </p:txBody>
+      </p:sp>
+      <p:sp>
+        <p:nvSpPr>
+          <p:cNvPr id="24" name="TextBox 23"/>
           <p:cNvSpPr txBox="1"/>
           <p:nvPr/>
         </p:nvSpPr>
         <p:spPr>
           <a:xfrm>
-            <a:off x="4253331" y="2331720"/>
-            <a:ext cx="822960" cy="457200"/>
+            <a:off x="4029303" y="1764792"/>
+            <a:ext cx="292608" cy="292608"/>
           </a:xfrm>
           <a:prstGeom prst="rect">
             <a:avLst/>
@@ -3750,9 +4013,9 @@
           <a:p>
             <a:pPr algn="ctr"/>
             <a:r>
-              <a:rPr sz="1800" b="1">
+              <a:rPr sz="1000" b="1">
                 <a:solidFill>
-                  <a:srgbClr val="FFFFFF"/>
+                  <a:srgbClr val="1F4E79"/>
                 </a:solidFill>
                 <a:latin typeface="Noto Sans CJK JP"/>
               </a:rPr>
@@ -3763,14 +4026,14 @@
       </p:sp>
       <p:sp>
         <p:nvSpPr>
-          <p:cNvPr id="18" name="Rounded Rectangle 17"/>
+          <p:cNvPr id="25" name="Rounded Rectangle 24"/>
           <p:cNvSpPr/>
           <p:nvPr/>
         </p:nvSpPr>
         <p:spPr>
           <a:xfrm>
-            <a:off x="3316071" y="3200400"/>
-            <a:ext cx="2697480" cy="1188720"/>
+            <a:off x="3316071" y="3246120"/>
+            <a:ext cx="2697480" cy="1097280"/>
           </a:xfrm>
           <a:prstGeom prst="roundRect">
             <a:avLst>
@@ -3808,14 +4071,14 @@
       </p:sp>
       <p:sp>
         <p:nvSpPr>
-          <p:cNvPr id="19" name="Rectangle 18"/>
+          <p:cNvPr id="26" name="Rectangle 25"/>
           <p:cNvSpPr/>
           <p:nvPr/>
         </p:nvSpPr>
         <p:spPr>
           <a:xfrm>
-            <a:off x="3316071" y="3200400"/>
-            <a:ext cx="109728" cy="1188720"/>
+            <a:off x="3316071" y="3246120"/>
+            <a:ext cx="109728" cy="1097280"/>
           </a:xfrm>
           <a:prstGeom prst="rect">
             <a:avLst/>
@@ -3851,13 +4114,13 @@
       </p:sp>
       <p:sp>
         <p:nvSpPr>
-          <p:cNvPr id="20" name="TextBox 19"/>
+          <p:cNvPr id="27" name="TextBox 26"/>
           <p:cNvSpPr txBox="1"/>
           <p:nvPr/>
         </p:nvSpPr>
         <p:spPr>
           <a:xfrm>
-            <a:off x="3517239" y="3310128"/>
+            <a:off x="3517239" y="3355848"/>
             <a:ext cx="2377440" cy="320040"/>
           </a:xfrm>
           <a:prstGeom prst="rect">
@@ -3886,13 +4149,13 @@
       </p:sp>
       <p:sp>
         <p:nvSpPr>
-          <p:cNvPr id="21" name="TextBox 20"/>
+          <p:cNvPr id="28" name="TextBox 27"/>
           <p:cNvSpPr txBox="1"/>
           <p:nvPr/>
         </p:nvSpPr>
         <p:spPr>
           <a:xfrm>
-            <a:off x="3517239" y="3611880"/>
+            <a:off x="3517239" y="3657600"/>
             <a:ext cx="2377440" cy="502920"/>
           </a:xfrm>
           <a:prstGeom prst="rect">
@@ -3922,20 +4185,20 @@
       </p:sp>
       <p:sp>
         <p:nvSpPr>
-          <p:cNvPr id="22" name="Oval 21"/>
+          <p:cNvPr id="29" name="Oval 28"/>
           <p:cNvSpPr/>
           <p:nvPr/>
         </p:nvSpPr>
         <p:spPr>
           <a:xfrm>
-            <a:off x="7115403" y="2148840"/>
-            <a:ext cx="822960" cy="822960"/>
+            <a:off x="6946239" y="1819656"/>
+            <a:ext cx="1234440" cy="1234440"/>
           </a:xfrm>
           <a:prstGeom prst="ellipse">
             <a:avLst/>
           </a:prstGeom>
           <a:solidFill>
-            <a:srgbClr val="1F4E79"/>
+            <a:srgbClr val="D0D8E0"/>
           </a:solidFill>
           <a:ln>
             <a:noFill/>
@@ -3963,16 +4226,83 @@
           </a:p>
         </p:txBody>
       </p:sp>
-      <p:sp>
-        <p:nvSpPr>
-          <p:cNvPr id="23" name="TextBox 22"/>
+      <p:pic>
+        <p:nvPicPr>
+          <p:cNvPr id="30" name="Picture 29" descr="icon_lab_circle.png"/>
+          <p:cNvPicPr>
+            <a:picLocks noChangeAspect="1"/>
+          </p:cNvPicPr>
+          <p:nvPr/>
+        </p:nvPicPr>
+        <p:blipFill>
+          <a:blip r:embed="rId4"/>
+          <a:stretch>
+            <a:fillRect/>
+          </a:stretch>
+        </p:blipFill>
+        <p:spPr>
+          <a:xfrm>
+            <a:off x="6909663" y="1783080"/>
+            <a:ext cx="1234440" cy="1234440"/>
+          </a:xfrm>
+          <a:prstGeom prst="rect">
+            <a:avLst/>
+          </a:prstGeom>
+        </p:spPr>
+      </p:pic>
+      <p:sp>
+        <p:nvSpPr>
+          <p:cNvPr id="31" name="Oval 30"/>
+          <p:cNvSpPr/>
+          <p:nvPr/>
+        </p:nvSpPr>
+        <p:spPr>
+          <a:xfrm>
+            <a:off x="6891375" y="1764792"/>
+            <a:ext cx="292608" cy="292608"/>
+          </a:xfrm>
+          <a:prstGeom prst="ellipse">
+            <a:avLst/>
+          </a:prstGeom>
+          <a:solidFill>
+            <a:srgbClr val="F2C94C"/>
+          </a:solidFill>
+          <a:ln>
+            <a:noFill/>
+          </a:ln>
+        </p:spPr>
+        <p:style>
+          <a:lnRef idx="1">
+            <a:schemeClr val="accent1"/>
+          </a:lnRef>
+          <a:fillRef idx="3">
+            <a:schemeClr val="accent1"/>
+          </a:fillRef>
+          <a:effectRef idx="2">
+            <a:schemeClr val="accent1"/>
+          </a:effectRef>
+          <a:fontRef idx="minor">
+            <a:schemeClr val="lt1"/>
+          </a:fontRef>
+        </p:style>
+        <p:txBody>
+          <a:bodyPr rtlCol="0" anchor="ctr"/>
+          <a:lstStyle/>
+          <a:p>
+            <a:pPr algn="ctr"/>
+          </a:p>
+        </p:txBody>
+      </p:sp>
+      <p:sp>
+        <p:nvSpPr>
+          <p:cNvPr id="32" name="TextBox 31"/>
           <p:cNvSpPr txBox="1"/>
           <p:nvPr/>
         </p:nvSpPr>
         <p:spPr>
           <a:xfrm>
-            <a:off x="7115403" y="2331720"/>
-            <a:ext cx="822960" cy="457200"/>
+            <a:off x="6891375" y="1764792"/>
+            <a:ext cx="292608" cy="292608"/>
           </a:xfrm>
           <a:prstGeom prst="rect">
             <a:avLst/>
@@ -3987,9 +4317,9 @@
           <a:p>
             <a:pPr algn="ctr"/>
             <a:r>
-              <a:rPr sz="1800" b="1">
+              <a:rPr sz="1000" b="1">
                 <a:solidFill>
-                  <a:srgbClr val="FFFFFF"/>
+                  <a:srgbClr val="1F4E79"/>
                 </a:solidFill>
                 <a:latin typeface="Noto Sans CJK JP"/>
               </a:rPr>
@@ -4000,14 +4330,14 @@
       </p:sp>
       <p:sp>
         <p:nvSpPr>
-          <p:cNvPr id="24" name="Rounded Rectangle 23"/>
+          <p:cNvPr id="33" name="Rounded Rectangle 32"/>
           <p:cNvSpPr/>
           <p:nvPr/>
         </p:nvSpPr>
         <p:spPr>
           <a:xfrm>
-            <a:off x="6178143" y="3200400"/>
-            <a:ext cx="2697480" cy="1188720"/>
+            <a:off x="6178143" y="3246120"/>
+            <a:ext cx="2697480" cy="1097280"/>
           </a:xfrm>
           <a:prstGeom prst="roundRect">
             <a:avLst>
@@ -4045,14 +4375,14 @@
       </p:sp>
       <p:sp>
         <p:nvSpPr>
-          <p:cNvPr id="25" name="Rectangle 24"/>
+          <p:cNvPr id="34" name="Rectangle 33"/>
           <p:cNvSpPr/>
           <p:nvPr/>
         </p:nvSpPr>
         <p:spPr>
           <a:xfrm>
-            <a:off x="6178143" y="3200400"/>
-            <a:ext cx="109728" cy="1188720"/>
+            <a:off x="6178143" y="3246120"/>
+            <a:ext cx="109728" cy="1097280"/>
           </a:xfrm>
           <a:prstGeom prst="rect">
             <a:avLst/>
@@ -4088,13 +4418,13 @@
       </p:sp>
       <p:sp>
         <p:nvSpPr>
-          <p:cNvPr id="26" name="TextBox 25"/>
+          <p:cNvPr id="35" name="TextBox 34"/>
           <p:cNvSpPr txBox="1"/>
           <p:nvPr/>
         </p:nvSpPr>
         <p:spPr>
           <a:xfrm>
-            <a:off x="6379311" y="3310128"/>
+            <a:off x="6379311" y="3355848"/>
             <a:ext cx="2377440" cy="320040"/>
           </a:xfrm>
           <a:prstGeom prst="rect">
@@ -4123,13 +4453,13 @@
       </p:sp>
       <p:sp>
         <p:nvSpPr>
-          <p:cNvPr id="27" name="TextBox 26"/>
+          <p:cNvPr id="36" name="TextBox 35"/>
           <p:cNvSpPr txBox="1"/>
           <p:nvPr/>
         </p:nvSpPr>
         <p:spPr>
           <a:xfrm>
-            <a:off x="6379311" y="3611880"/>
+            <a:off x="6379311" y="3657600"/>
             <a:ext cx="2377440" cy="502920"/>
           </a:xfrm>
           <a:prstGeom prst="rect">
@@ -4159,20 +4489,20 @@
       </p:sp>
       <p:sp>
         <p:nvSpPr>
-          <p:cNvPr id="28" name="Oval 27"/>
+          <p:cNvPr id="37" name="Oval 36"/>
           <p:cNvSpPr/>
           <p:nvPr/>
         </p:nvSpPr>
         <p:spPr>
           <a:xfrm>
-            <a:off x="9977475" y="2148840"/>
-            <a:ext cx="822960" cy="822960"/>
+            <a:off x="9808311" y="1819656"/>
+            <a:ext cx="1234440" cy="1234440"/>
           </a:xfrm>
           <a:prstGeom prst="ellipse">
             <a:avLst/>
           </a:prstGeom>
           <a:solidFill>
-            <a:srgbClr val="1F4E79"/>
+            <a:srgbClr val="D0D8E0"/>
           </a:solidFill>
           <a:ln>
             <a:noFill/>
@@ -4200,16 +4530,83 @@
           </a:p>
         </p:txBody>
       </p:sp>
-      <p:sp>
-        <p:nvSpPr>
-          <p:cNvPr id="29" name="TextBox 28"/>
+      <p:pic>
+        <p:nvPicPr>
+          <p:cNvPr id="38" name="Picture 37" descr="icon_yokogawa_circle.png"/>
+          <p:cNvPicPr>
+            <a:picLocks noChangeAspect="1"/>
+          </p:cNvPicPr>
+          <p:nvPr/>
+        </p:nvPicPr>
+        <p:blipFill>
+          <a:blip r:embed="rId5"/>
+          <a:stretch>
+            <a:fillRect/>
+          </a:stretch>
+        </p:blipFill>
+        <p:spPr>
+          <a:xfrm>
+            <a:off x="9771735" y="1783080"/>
+            <a:ext cx="1234440" cy="1234440"/>
+          </a:xfrm>
+          <a:prstGeom prst="rect">
+            <a:avLst/>
+          </a:prstGeom>
+        </p:spPr>
+      </p:pic>
+      <p:sp>
+        <p:nvSpPr>
+          <p:cNvPr id="39" name="Oval 38"/>
+          <p:cNvSpPr/>
+          <p:nvPr/>
+        </p:nvSpPr>
+        <p:spPr>
+          <a:xfrm>
+            <a:off x="9753447" y="1764792"/>
+            <a:ext cx="292608" cy="292608"/>
+          </a:xfrm>
+          <a:prstGeom prst="ellipse">
+            <a:avLst/>
+          </a:prstGeom>
+          <a:solidFill>
+            <a:srgbClr val="F2C94C"/>
+          </a:solidFill>
+          <a:ln>
+            <a:noFill/>
+          </a:ln>
+        </p:spPr>
+        <p:style>
+          <a:lnRef idx="1">
+            <a:schemeClr val="accent1"/>
+          </a:lnRef>
+          <a:fillRef idx="3">
+            <a:schemeClr val="accent1"/>
+          </a:fillRef>
+          <a:effectRef idx="2">
+            <a:schemeClr val="accent1"/>
+          </a:effectRef>
+          <a:fontRef idx="minor">
+            <a:schemeClr val="lt1"/>
+          </a:fontRef>
+        </p:style>
+        <p:txBody>
+          <a:bodyPr rtlCol="0" anchor="ctr"/>
+          <a:lstStyle/>
+          <a:p>
+            <a:pPr algn="ctr"/>
+          </a:p>
+        </p:txBody>
+      </p:sp>
+      <p:sp>
+        <p:nvSpPr>
+          <p:cNvPr id="40" name="TextBox 39"/>
           <p:cNvSpPr txBox="1"/>
           <p:nvPr/>
         </p:nvSpPr>
         <p:spPr>
           <a:xfrm>
-            <a:off x="9977475" y="2331720"/>
-            <a:ext cx="822960" cy="457200"/>
+            <a:off x="9753447" y="1764792"/>
+            <a:ext cx="292608" cy="292608"/>
           </a:xfrm>
           <a:prstGeom prst="rect">
             <a:avLst/>
@@ -4224,9 +4621,9 @@
           <a:p>
             <a:pPr algn="ctr"/>
             <a:r>
-              <a:rPr sz="1800" b="1">
+              <a:rPr sz="1000" b="1">
                 <a:solidFill>
-                  <a:srgbClr val="FFFFFF"/>
+                  <a:srgbClr val="1F4E79"/>
                 </a:solidFill>
                 <a:latin typeface="Noto Sans CJK JP"/>
               </a:rPr>
@@ -4237,14 +4634,14 @@
       </p:sp>
       <p:sp>
         <p:nvSpPr>
-          <p:cNvPr id="30" name="Rounded Rectangle 29"/>
+          <p:cNvPr id="41" name="Rounded Rectangle 40"/>
           <p:cNvSpPr/>
           <p:nvPr/>
         </p:nvSpPr>
         <p:spPr>
           <a:xfrm>
-            <a:off x="9040215" y="3200400"/>
-            <a:ext cx="2697480" cy="1188720"/>
+            <a:off x="9040215" y="3246120"/>
+            <a:ext cx="2697480" cy="1097280"/>
           </a:xfrm>
           <a:prstGeom prst="roundRect">
             <a:avLst>
@@ -4282,14 +4679,14 @@
       </p:sp>
       <p:sp>
         <p:nvSpPr>
-          <p:cNvPr id="31" name="Rectangle 30"/>
+          <p:cNvPr id="42" name="Rectangle 41"/>
           <p:cNvSpPr/>
           <p:nvPr/>
         </p:nvSpPr>
         <p:spPr>
           <a:xfrm>
-            <a:off x="9040215" y="3200400"/>
-            <a:ext cx="109728" cy="1188720"/>
+            <a:off x="9040215" y="3246120"/>
+            <a:ext cx="109728" cy="1097280"/>
           </a:xfrm>
           <a:prstGeom prst="rect">
             <a:avLst/>
@@ -4325,13 +4722,13 @@
       </p:sp>
       <p:sp>
         <p:nvSpPr>
-          <p:cNvPr id="32" name="TextBox 31"/>
+          <p:cNvPr id="43" name="TextBox 42"/>
           <p:cNvSpPr txBox="1"/>
           <p:nvPr/>
         </p:nvSpPr>
         <p:spPr>
           <a:xfrm>
-            <a:off x="9241383" y="3310128"/>
+            <a:off x="9241383" y="3355848"/>
             <a:ext cx="2377440" cy="320040"/>
           </a:xfrm>
           <a:prstGeom prst="rect">
@@ -4360,13 +4757,13 @@
       </p:sp>
       <p:sp>
         <p:nvSpPr>
-          <p:cNvPr id="33" name="TextBox 32"/>
+          <p:cNvPr id="44" name="TextBox 43"/>
           <p:cNvSpPr txBox="1"/>
           <p:nvPr/>
         </p:nvSpPr>
         <p:spPr>
           <a:xfrm>
-            <a:off x="9241383" y="3611880"/>
+            <a:off x="9241383" y="3657600"/>
             <a:ext cx="2377440" cy="502920"/>
           </a:xfrm>
           <a:prstGeom prst="rect">
@@ -4396,7 +4793,7 @@
       </p:sp>
       <p:sp>
         <p:nvSpPr>
-          <p:cNvPr id="34" name="Rounded Rectangle 33"/>
+          <p:cNvPr id="45" name="Rounded Rectangle 44"/>
           <p:cNvSpPr/>
           <p:nvPr/>
         </p:nvSpPr>
@@ -4441,7 +4838,7 @@
       </p:sp>
       <p:sp>
         <p:nvSpPr>
-          <p:cNvPr id="35" name="TextBox 34"/>
+          <p:cNvPr id="46" name="TextBox 45"/>
           <p:cNvSpPr txBox="1"/>
           <p:nvPr/>
         </p:nvSpPr>
@@ -4476,7 +4873,7 @@
       </p:sp>
       <p:sp>
         <p:nvSpPr>
-          <p:cNvPr id="36" name="Oval 35"/>
+          <p:cNvPr id="47" name="Oval 46"/>
           <p:cNvSpPr/>
           <p:nvPr/>
         </p:nvSpPr>
@@ -4519,7 +4916,7 @@
       </p:sp>
       <p:sp>
         <p:nvSpPr>
-          <p:cNvPr id="37" name="TextBox 36"/>
+          <p:cNvPr id="48" name="TextBox 47"/>
           <p:cNvSpPr txBox="1"/>
           <p:nvPr/>
         </p:nvSpPr>
@@ -4554,7 +4951,7 @@
       </p:sp>
       <p:sp>
         <p:nvSpPr>
-          <p:cNvPr id="38" name="TextBox 37"/>
+          <p:cNvPr id="49" name="TextBox 48"/>
           <p:cNvSpPr txBox="1"/>
           <p:nvPr/>
         </p:nvSpPr>
@@ -4590,7 +4987,7 @@
       </p:sp>
       <p:sp>
         <p:nvSpPr>
-          <p:cNvPr id="39" name="Oval 38"/>
+          <p:cNvPr id="50" name="Oval 49"/>
           <p:cNvSpPr/>
           <p:nvPr/>
         </p:nvSpPr>
@@ -4633,7 +5030,7 @@
       </p:sp>
       <p:sp>
         <p:nvSpPr>
-          <p:cNvPr id="40" name="TextBox 39"/>
+          <p:cNvPr id="51" name="TextBox 50"/>
           <p:cNvSpPr txBox="1"/>
           <p:nvPr/>
         </p:nvSpPr>
@@ -4668,7 +5065,7 @@
       </p:sp>
       <p:sp>
         <p:nvSpPr>
-          <p:cNvPr id="41" name="TextBox 40"/>
+          <p:cNvPr id="52" name="TextBox 51"/>
           <p:cNvSpPr txBox="1"/>
           <p:nvPr/>
         </p:nvSpPr>
@@ -4704,7 +5101,7 @@
       </p:sp>
       <p:sp>
         <p:nvSpPr>
-          <p:cNvPr id="42" name="Oval 41"/>
+          <p:cNvPr id="53" name="Oval 52"/>
           <p:cNvSpPr/>
           <p:nvPr/>
         </p:nvSpPr>
@@ -4747,7 +5144,7 @@
       </p:sp>
       <p:sp>
         <p:nvSpPr>
-          <p:cNvPr id="43" name="TextBox 42"/>
+          <p:cNvPr id="54" name="TextBox 53"/>
           <p:cNvSpPr txBox="1"/>
           <p:nvPr/>
         </p:nvSpPr>
@@ -4782,7 +5179,7 @@
       </p:sp>
       <p:sp>
         <p:nvSpPr>
-          <p:cNvPr id="44" name="TextBox 43"/>
+          <p:cNvPr id="55" name="TextBox 54"/>
           <p:cNvSpPr txBox="1"/>
           <p:nvPr/>
         </p:nvSpPr>
@@ -4818,7 +5215,7 @@
       </p:sp>
       <p:sp>
         <p:nvSpPr>
-          <p:cNvPr id="45" name="Oval 44"/>
+          <p:cNvPr id="56" name="Oval 55"/>
           <p:cNvSpPr/>
           <p:nvPr/>
         </p:nvSpPr>
@@ -4861,7 +5258,7 @@
       </p:sp>
       <p:sp>
         <p:nvSpPr>
-          <p:cNvPr id="46" name="TextBox 45"/>
+          <p:cNvPr id="57" name="TextBox 56"/>
           <p:cNvSpPr txBox="1"/>
           <p:nvPr/>
         </p:nvSpPr>
@@ -4896,7 +5293,7 @@
       </p:sp>
       <p:sp>
         <p:nvSpPr>
-          <p:cNvPr id="47" name="TextBox 46"/>
+          <p:cNvPr id="58" name="TextBox 57"/>
           <p:cNvSpPr txBox="1"/>
           <p:nvPr/>
         </p:nvSpPr>

</xml_diff>